<commit_message>
New TP04 with GitHub address
New TP04 with GitHub address
</commit_message>
<xml_diff>
--- a/TP04 Project Presentation - Doanh Pham Ibrahima Doumbia Naser Zaghwan.pptx
+++ b/TP04 Project Presentation - Doanh Pham Ibrahima Doumbia Naser Zaghwan.pptx
@@ -5590,6 +5590,15 @@
           <a:bodyPr/>
           <a:lstStyle/>
           <a:p>
+            <a:r>
+              <a:rPr lang="en-US">
+                <a:hlinkClick r:id="rId2"/>
+              </a:rPr>
+              <a:t>https://github.com/Doumex01/TP04---Final-Presentation</a:t>
+            </a:r>
+            <a:endParaRPr lang="en-US"/>
+          </a:p>
+          <a:p>
             <a:endParaRPr lang="en-US" dirty="0"/>
           </a:p>
         </p:txBody>

</xml_diff>